<commit_message>
Match Karim section backup to Chrome review refinements
</commit_message>
<xml_diff>
--- a/presentations/karim-presentation2-section.pptx
+++ b/presentations/karim-presentation2-section.pptx
@@ -2,19 +2,19 @@
 <file path=ppt/presentation.xml><?xml version="1.0" encoding="utf-8"?>
 <p:presentation xmlns:p="http://schemas.openxmlformats.org/presentationml/2006/main">
   <p:sldMasterIdLst>
-    <p:sldMasterId xmlns:r="http://schemas.openxmlformats.org/officeDocument/2006/relationships" id="2147483648" r:id="Re462350623884a26"/>
+    <p:sldMasterId xmlns:r="http://schemas.openxmlformats.org/officeDocument/2006/relationships" id="2147483648" r:id="Re0e5654751a44434"/>
   </p:sldMasterIdLst>
   <p:notesMasterIdLst>
-    <p:notesMasterId xmlns:r="http://schemas.openxmlformats.org/officeDocument/2006/relationships" r:id="Re772da0c7b7e4574"/>
+    <p:notesMasterId xmlns:r="http://schemas.openxmlformats.org/officeDocument/2006/relationships" r:id="R9594dc42b8374b02"/>
   </p:notesMasterIdLst>
   <p:sldIdLst>
-    <p:sldId xmlns:r="http://schemas.openxmlformats.org/officeDocument/2006/relationships" id="256" r:id="R9730b4d66ea94893"/>
-    <p:sldId xmlns:r="http://schemas.openxmlformats.org/officeDocument/2006/relationships" id="257" r:id="Rc92dd189e6884799"/>
-    <p:sldId xmlns:r="http://schemas.openxmlformats.org/officeDocument/2006/relationships" id="258" r:id="Rcd531fa4bbcb453d"/>
-    <p:sldId xmlns:r="http://schemas.openxmlformats.org/officeDocument/2006/relationships" id="259" r:id="Rbe6a9dd852fe485c"/>
-    <p:sldId xmlns:r="http://schemas.openxmlformats.org/officeDocument/2006/relationships" id="260" r:id="R1f8d210e54ea4d57"/>
-    <p:sldId xmlns:r="http://schemas.openxmlformats.org/officeDocument/2006/relationships" id="261" r:id="Rc9c449c36bdf4df1"/>
-    <p:sldId xmlns:r="http://schemas.openxmlformats.org/officeDocument/2006/relationships" id="262" r:id="R3dd862416aeb4851"/>
+    <p:sldId xmlns:r="http://schemas.openxmlformats.org/officeDocument/2006/relationships" id="256" r:id="Rd80115d0bed544f0"/>
+    <p:sldId xmlns:r="http://schemas.openxmlformats.org/officeDocument/2006/relationships" id="257" r:id="R16b2a5144e6c4a43"/>
+    <p:sldId xmlns:r="http://schemas.openxmlformats.org/officeDocument/2006/relationships" id="258" r:id="R9f68e0a425394e73"/>
+    <p:sldId xmlns:r="http://schemas.openxmlformats.org/officeDocument/2006/relationships" id="259" r:id="R9002573fe6d845d7"/>
+    <p:sldId xmlns:r="http://schemas.openxmlformats.org/officeDocument/2006/relationships" id="260" r:id="R6405e9a664154d18"/>
+    <p:sldId xmlns:r="http://schemas.openxmlformats.org/officeDocument/2006/relationships" id="261" r:id="Rc3755a4c61a74553"/>
+    <p:sldId xmlns:r="http://schemas.openxmlformats.org/officeDocument/2006/relationships" id="262" r:id="R11c5182fde644b03"/>
   </p:sldIdLst>
   <p:sldSz cx="12192000" cy="6858000"/>
   <p:notesSz cx="6858000" cy="9144000"/>
@@ -458,7 +458,7 @@
           </a:p>
           <a:p xmlns:a="http://schemas.openxmlformats.org/drawingml/2006/main">
             <a:r>
-              <a:t>Our deliverable is a research paper supported by reproducible experiments. It serves practitioners by answering two questions: what coverage is attainable at a chosen empirical reliability target, and whether SDM adds value beyond cheap raw-softmax and temperature-scaled baselines. We preserve the same checkpoint, label space and evaluation images within a comparison, record calibration support, and retain negative results. The supporting notebooks export configurations, identities, per-image decisions and aggregate metrics. The paper connects those outputs to accepted accuracy, coverage, probability calibration, error ranking, confusions and limitations. The project does not claim a production inspection product or a general safety guarantee. We considered several distinct confidence measurements because calibration quality, ranking quality and admission feasibility can disagree. A useful final contribution can be a carefully evidenced limitation of SDM transfer, not only a positive result. The full corrupted/OOD comparison remains unfinished, so today’s conclusion is deliberately restricted to completed clean tasks. Karim confirmed on October 29 that the team received feedback from Allen Schmaltz. The specific recommendations and changes made in response have not yet been supplied. Acknowledge the feedback without inventing a quote, meeting format, endorsement or validation outcome. Questions for expert feedback include why a qualifying region can fail despite useful error ranking, and how to compare global empirical thresholds with SDM’s class-conditional construction.</a:t>
+              <a:t>Our deliverable is a reproducible benchmark and research paper for vision practitioners deciding which predictions to accept or send for review. We ask what coverage is attainable at a target accepted accuracy, and when SDM adds value beyond calibrated softmax. We compare policies on the same checkpoint and evaluation images within each task, and report negative results alongside positive ones. Calibration quality, error ranking and useful admission coverage can disagree. Today’s conclusions cover completed clean tasks; matched corruption and OOD evaluation remains unfinished.</a:t>
             </a:r>
           </a:p>
           <a:p xmlns:a="http://schemas.openxmlformats.org/drawingml/2006/main">
@@ -468,7 +468,17 @@
           </a:p>
           <a:p xmlns:a="http://schemas.openxmlformats.org/drawingml/2006/main">
             <a:r>
-              <a:t>Sources: docs/assets/clean-analysis-2026-10-29/evidence.json (SHA256 b90dc4b3c7c64bd6dd8fe37307f7d9f1f9df264eb480d5e86703fc76efe74a44); docs/research-writeup.md; docs/experiment-design.md. Presentation 2 guidance supplied by the team, pages 1–5. Speaking assignments and timings are suggestions based on the chat, not confirmed team decisions.</a:t>
+              <a:t>Allen Schmaltz feedback: [TEAM: add his key advice and the changes made in response. Feedback was confirmed by Karim; do not infer endorsement.]</a:t>
+            </a:r>
+          </a:p>
+          <a:p xmlns:a="http://schemas.openxmlformats.org/drawingml/2006/main">
+            <a:r>
+              <a:t/>
+            </a:r>
+          </a:p>
+          <a:p xmlns:a="http://schemas.openxmlformats.org/drawingml/2006/main">
+            <a:r>
+              <a:t>Sources: docs/research-writeup.md; docs/experiment-design.md; docs/assets/clean-analysis-2026-10-29/evidence.json.</a:t>
             </a:r>
           </a:p>
         </p:txBody>
@@ -1045,7 +1055,7 @@
           <p:cNvPr id="3" name="Title">
             <a:extLst xmlns:a="http://schemas.openxmlformats.org/drawingml/2006/main">
               <a:ext uri="{FF2B5EF4-FFF2-40B4-BE49-F238E27FC236}">
-                <a16:creationId xmlns:a16="http://schemas.microsoft.com/office/drawing/2014/main" id="{2272177D-C351-4D28-BF1C-C3F11F6431AD}"/>
+                <a16:creationId xmlns:a16="http://schemas.microsoft.com/office/drawing/2014/main" id="{C76FC6EC-309E-4707-96B2-31C9DB7CCF76}"/>
               </a:ext>
             </a:extLst>
           </p:cNvPr>
@@ -1274,7 +1284,7 @@
           <p:cNvPr id="2" name="Subtitle">
             <a:extLst xmlns:a="http://schemas.openxmlformats.org/drawingml/2006/main">
               <a:ext uri="{FF2B5EF4-FFF2-40B4-BE49-F238E27FC236}">
-                <a16:creationId xmlns:a16="http://schemas.microsoft.com/office/drawing/2014/main" id="{8FBD1D3B-7181-4E7B-AF3D-E0C4926F37B1}"/>
+                <a16:creationId xmlns:a16="http://schemas.microsoft.com/office/drawing/2014/main" id="{55B97E41-894F-4F84-9E53-16477546A2D4}"/>
               </a:ext>
             </a:extLst>
           </p:cNvPr>
@@ -1520,7 +1530,7 @@
           <p:cNvPr id="2" name="Section title">
             <a:extLst xmlns:a="http://schemas.openxmlformats.org/drawingml/2006/main">
               <a:ext uri="{FF2B5EF4-FFF2-40B4-BE49-F238E27FC236}">
-                <a16:creationId xmlns:a16="http://schemas.microsoft.com/office/drawing/2014/main" id="{4AC4FD19-4095-4163-BF93-EEF1348C25ED}"/>
+                <a16:creationId xmlns:a16="http://schemas.microsoft.com/office/drawing/2014/main" id="{03927155-5644-437E-9972-DFB450F8D8F1}"/>
               </a:ext>
             </a:extLst>
           </p:cNvPr>
@@ -1766,7 +1776,7 @@
           <p:cNvPr id="3" name="Title">
             <a:extLst xmlns:a="http://schemas.openxmlformats.org/drawingml/2006/main">
               <a:ext uri="{FF2B5EF4-FFF2-40B4-BE49-F238E27FC236}">
-                <a16:creationId xmlns:a16="http://schemas.microsoft.com/office/drawing/2014/main" id="{BB48FC85-A04D-43A1-BC0F-43EEC59AF073}"/>
+                <a16:creationId xmlns:a16="http://schemas.microsoft.com/office/drawing/2014/main" id="{321A84D8-BB02-4AE2-8E05-6769BCABB3E8}"/>
               </a:ext>
             </a:extLst>
           </p:cNvPr>
@@ -1995,7 +2005,7 @@
           <p:cNvPr id="2" name="Body">
             <a:extLst xmlns:a="http://schemas.openxmlformats.org/drawingml/2006/main">
               <a:ext uri="{FF2B5EF4-FFF2-40B4-BE49-F238E27FC236}">
-                <a16:creationId xmlns:a16="http://schemas.microsoft.com/office/drawing/2014/main" id="{7AB1E6B3-0D37-42AE-AD94-9E7D1B2C0A50}"/>
+                <a16:creationId xmlns:a16="http://schemas.microsoft.com/office/drawing/2014/main" id="{7F8C9244-AAEA-43F3-9C09-7E7A04E61B0F}"/>
               </a:ext>
             </a:extLst>
           </p:cNvPr>
@@ -2241,7 +2251,7 @@
           <p:cNvPr id="4" name="Title">
             <a:extLst xmlns:a="http://schemas.openxmlformats.org/drawingml/2006/main">
               <a:ext uri="{FF2B5EF4-FFF2-40B4-BE49-F238E27FC236}">
-                <a16:creationId xmlns:a16="http://schemas.microsoft.com/office/drawing/2014/main" id="{33ACF54F-9A17-4711-8D35-35776DC3FDA4}"/>
+                <a16:creationId xmlns:a16="http://schemas.microsoft.com/office/drawing/2014/main" id="{2E480369-AF82-4134-9728-BCE6C8E592EF}"/>
               </a:ext>
             </a:extLst>
           </p:cNvPr>
@@ -2470,7 +2480,7 @@
           <p:cNvPr id="2" name="Left column">
             <a:extLst xmlns:a="http://schemas.openxmlformats.org/drawingml/2006/main">
               <a:ext uri="{FF2B5EF4-FFF2-40B4-BE49-F238E27FC236}">
-                <a16:creationId xmlns:a16="http://schemas.microsoft.com/office/drawing/2014/main" id="{93318945-B95A-4BF3-A219-D832D6A34600}"/>
+                <a16:creationId xmlns:a16="http://schemas.microsoft.com/office/drawing/2014/main" id="{512C7D80-4596-4A81-A052-68F527A80F59}"/>
               </a:ext>
             </a:extLst>
           </p:cNvPr>
@@ -2699,7 +2709,7 @@
           <p:cNvPr id="3" name="Right column">
             <a:extLst xmlns:a="http://schemas.openxmlformats.org/drawingml/2006/main">
               <a:ext uri="{FF2B5EF4-FFF2-40B4-BE49-F238E27FC236}">
-                <a16:creationId xmlns:a16="http://schemas.microsoft.com/office/drawing/2014/main" id="{1C9FEB19-D79E-4505-877C-A2A0700C656C}"/>
+                <a16:creationId xmlns:a16="http://schemas.microsoft.com/office/drawing/2014/main" id="{5D759D9F-D46D-45CB-B4A4-8FD5EAD7C045}"/>
               </a:ext>
             </a:extLst>
           </p:cNvPr>
@@ -2945,7 +2955,7 @@
           <p:cNvPr id="3" name="Title">
             <a:extLst xmlns:a="http://schemas.openxmlformats.org/drawingml/2006/main">
               <a:ext uri="{FF2B5EF4-FFF2-40B4-BE49-F238E27FC236}">
-                <a16:creationId xmlns:a16="http://schemas.microsoft.com/office/drawing/2014/main" id="{7B30FC20-7540-4F95-82D0-96A31C8EB994}"/>
+                <a16:creationId xmlns:a16="http://schemas.microsoft.com/office/drawing/2014/main" id="{0BFCAE94-393A-4A27-8AF5-BC0C315787C7}"/>
               </a:ext>
             </a:extLst>
           </p:cNvPr>
@@ -3174,7 +3184,7 @@
           <p:cNvPr id="2" name="Left column">
             <a:extLst xmlns:a="http://schemas.openxmlformats.org/drawingml/2006/main">
               <a:ext uri="{FF2B5EF4-FFF2-40B4-BE49-F238E27FC236}">
-                <a16:creationId xmlns:a16="http://schemas.microsoft.com/office/drawing/2014/main" id="{9DCD5B12-2568-4650-A7F8-0CF8647EE766}"/>
+                <a16:creationId xmlns:a16="http://schemas.microsoft.com/office/drawing/2014/main" id="{8E951598-235B-4CFA-8EF6-D395AAEE860A}"/>
               </a:ext>
             </a:extLst>
           </p:cNvPr>
@@ -3441,12 +3451,12 @@
   </p:cSld>
   <p:clrMap bg1="lt1" tx1="dk1" bg2="lt2" tx2="dk2" accent1="accent1" accent2="accent2" accent3="accent3" accent4="accent4" accent5="accent5" accent6="accent6" hlink="hlink" folHlink="folHlink"/>
   <p:sldLayoutIdLst>
-    <p:sldLayoutId xmlns:r="http://schemas.openxmlformats.org/officeDocument/2006/relationships" id="2147483649" r:id="Rff7b39da83cf4287"/>
-    <p:sldLayoutId xmlns:r="http://schemas.openxmlformats.org/officeDocument/2006/relationships" id="2147483650" r:id="R368f93266d8e4d85"/>
-    <p:sldLayoutId xmlns:r="http://schemas.openxmlformats.org/officeDocument/2006/relationships" id="2147483651" r:id="Rf3dab238b357402a"/>
-    <p:sldLayoutId xmlns:r="http://schemas.openxmlformats.org/officeDocument/2006/relationships" id="2147483652" r:id="Rc5a058260b2348cc"/>
-    <p:sldLayoutId xmlns:r="http://schemas.openxmlformats.org/officeDocument/2006/relationships" id="2147483653" r:id="R29574bfe2e124f6a"/>
-    <p:sldLayoutId xmlns:r="http://schemas.openxmlformats.org/officeDocument/2006/relationships" id="2147483654" r:id="R8fe299f17e05442c"/>
+    <p:sldLayoutId xmlns:r="http://schemas.openxmlformats.org/officeDocument/2006/relationships" id="2147483649" r:id="Rc8efb26977264549"/>
+    <p:sldLayoutId xmlns:r="http://schemas.openxmlformats.org/officeDocument/2006/relationships" id="2147483650" r:id="Rea2b2260673a4f50"/>
+    <p:sldLayoutId xmlns:r="http://schemas.openxmlformats.org/officeDocument/2006/relationships" id="2147483651" r:id="Rea6a4dd778404c72"/>
+    <p:sldLayoutId xmlns:r="http://schemas.openxmlformats.org/officeDocument/2006/relationships" id="2147483652" r:id="R60a2b09ca90042f5"/>
+    <p:sldLayoutId xmlns:r="http://schemas.openxmlformats.org/officeDocument/2006/relationships" id="2147483653" r:id="R4f46f01a885e4c5a"/>
+    <p:sldLayoutId xmlns:r="http://schemas.openxmlformats.org/officeDocument/2006/relationships" id="2147483654" r:id="R695f1db914ef416c"/>
   </p:sldLayoutIdLst>
   <p:txStyles>
     <p:titleStyle>
@@ -4260,7 +4270,7 @@
           <p:cNvPr id="8" name="">
             <a:extLst xmlns:a="http://schemas.openxmlformats.org/drawingml/2006/main">
               <a:ext uri="{FF2B5EF4-FFF2-40B4-BE49-F238E27FC236}">
-                <a16:creationId xmlns:a16="http://schemas.microsoft.com/office/drawing/2014/main" id="{F7236A44-0055-4975-B0AB-A83673817F4D}"/>
+                <a16:creationId xmlns:a16="http://schemas.microsoft.com/office/drawing/2014/main" id="{59CD5FF3-492E-403F-BB19-DC16B2FE923B}"/>
               </a:ext>
             </a:extLst>
           </p:cNvPr>
@@ -4290,7 +4300,7 @@
           <p:cNvPr id="2" name="">
             <a:extLst xmlns:a="http://schemas.openxmlformats.org/drawingml/2006/main">
               <a:ext uri="{FF2B5EF4-FFF2-40B4-BE49-F238E27FC236}">
-                <a16:creationId xmlns:a16="http://schemas.microsoft.com/office/drawing/2014/main" id="{6018F4E4-1CE9-4EBF-86D1-A74B20486205}"/>
+                <a16:creationId xmlns:a16="http://schemas.microsoft.com/office/drawing/2014/main" id="{DAF12776-AA7A-42E9-B20C-EDAA2AA19B91}"/>
               </a:ext>
             </a:extLst>
           </p:cNvPr>
@@ -4369,7 +4379,7 @@
           <p:cNvPr id="3" name="">
             <a:extLst xmlns:a="http://schemas.openxmlformats.org/drawingml/2006/main">
               <a:ext uri="{FF2B5EF4-FFF2-40B4-BE49-F238E27FC236}">
-                <a16:creationId xmlns:a16="http://schemas.microsoft.com/office/drawing/2014/main" id="{B31B3EFE-17C8-4154-A582-7D897A945818}"/>
+                <a16:creationId xmlns:a16="http://schemas.microsoft.com/office/drawing/2014/main" id="{2333FF13-E2FA-44DC-8243-0E3D9B744092}"/>
               </a:ext>
             </a:extLst>
           </p:cNvPr>
@@ -4448,7 +4458,7 @@
           <p:cNvPr id="4" name="">
             <a:extLst xmlns:a="http://schemas.openxmlformats.org/drawingml/2006/main">
               <a:ext uri="{FF2B5EF4-FFF2-40B4-BE49-F238E27FC236}">
-                <a16:creationId xmlns:a16="http://schemas.microsoft.com/office/drawing/2014/main" id="{07D0DB94-DAB4-4B31-80BD-2D5B63FAC4D1}"/>
+                <a16:creationId xmlns:a16="http://schemas.microsoft.com/office/drawing/2014/main" id="{8CDCF5B2-8897-4AF5-A581-91B46E3B0D65}"/>
               </a:ext>
             </a:extLst>
           </p:cNvPr>
@@ -4590,7 +4600,7 @@
           <p:cNvPr id="5" name="">
             <a:extLst xmlns:a="http://schemas.openxmlformats.org/drawingml/2006/main">
               <a:ext uri="{FF2B5EF4-FFF2-40B4-BE49-F238E27FC236}">
-                <a16:creationId xmlns:a16="http://schemas.microsoft.com/office/drawing/2014/main" id="{DBBD0772-9B00-453B-A6F0-CDF079446EAF}"/>
+                <a16:creationId xmlns:a16="http://schemas.microsoft.com/office/drawing/2014/main" id="{8FAF52A0-74D4-410C-BBE8-B105ECEA6ECC}"/>
               </a:ext>
             </a:extLst>
           </p:cNvPr>
@@ -4669,7 +4679,7 @@
           <p:cNvPr id="6" name="">
             <a:extLst xmlns:a="http://schemas.openxmlformats.org/drawingml/2006/main">
               <a:ext uri="{FF2B5EF4-FFF2-40B4-BE49-F238E27FC236}">
-                <a16:creationId xmlns:a16="http://schemas.microsoft.com/office/drawing/2014/main" id="{1D2CDB37-FF5A-452C-99B1-DB07C3521733}"/>
+                <a16:creationId xmlns:a16="http://schemas.microsoft.com/office/drawing/2014/main" id="{7744484D-347A-445E-BB4A-58311C48B39F}"/>
               </a:ext>
             </a:extLst>
           </p:cNvPr>
@@ -4779,7 +4789,7 @@
           <p:cNvPr id="7" name="">
             <a:extLst xmlns:a="http://schemas.openxmlformats.org/drawingml/2006/main">
               <a:ext uri="{FF2B5EF4-FFF2-40B4-BE49-F238E27FC236}">
-                <a16:creationId xmlns:a16="http://schemas.microsoft.com/office/drawing/2014/main" id="{3BE6DF39-CAA1-4673-89BD-40A6B10503F2}"/>
+                <a16:creationId xmlns:a16="http://schemas.microsoft.com/office/drawing/2014/main" id="{1545B52A-DF26-4CA9-880B-99D4F3A7897F}"/>
               </a:ext>
             </a:extLst>
           </p:cNvPr>
@@ -4856,7 +4866,7 @@
     </p:spTree>
     <p:extLst>
       <p:ext uri="{BB962C8B-B14F-4D97-AF65-F5344CB8AC3E}">
-        <p14:creationId xmlns:p14="http://schemas.microsoft.com/office/powerpoint/2010/main" val="1736345349"/>
+        <p14:creationId xmlns:p14="http://schemas.microsoft.com/office/powerpoint/2010/main" val="1305725059"/>
       </p:ext>
     </p:extLst>
   </p:cSld>
@@ -4887,7 +4897,7 @@
           <p:cNvPr id="5" name="">
             <a:extLst xmlns:a="http://schemas.openxmlformats.org/drawingml/2006/main">
               <a:ext uri="{FF2B5EF4-FFF2-40B4-BE49-F238E27FC236}">
-                <a16:creationId xmlns:a16="http://schemas.microsoft.com/office/drawing/2014/main" id="{891C0F02-3E86-4B02-8D05-746AD57C4E44}"/>
+                <a16:creationId xmlns:a16="http://schemas.microsoft.com/office/drawing/2014/main" id="{B025B678-D19E-4DEA-BA55-A6D4045F9E25}"/>
               </a:ext>
             </a:extLst>
           </p:cNvPr>
@@ -4917,7 +4927,7 @@
           <p:cNvPr id="2" name="">
             <a:extLst xmlns:a="http://schemas.openxmlformats.org/drawingml/2006/main">
               <a:ext uri="{FF2B5EF4-FFF2-40B4-BE49-F238E27FC236}">
-                <a16:creationId xmlns:a16="http://schemas.microsoft.com/office/drawing/2014/main" id="{08CCF06A-4BE6-446F-B066-C67F01AE7C68}"/>
+                <a16:creationId xmlns:a16="http://schemas.microsoft.com/office/drawing/2014/main" id="{F5428D60-AB4C-4F3E-B9F9-51DBC20E3E4D}"/>
               </a:ext>
             </a:extLst>
           </p:cNvPr>
@@ -4996,7 +5006,7 @@
           <p:cNvPr id="3" name="Chart">
             <a:extLst xmlns:a="http://schemas.openxmlformats.org/drawingml/2006/main">
               <a:ext uri="{FF2B5EF4-FFF2-40B4-BE49-F238E27FC236}">
-                <a16:creationId xmlns:a16="http://schemas.microsoft.com/office/drawing/2014/main" id="{818D6F6A-7C5F-48A1-8036-9EB1BA50A86C}"/>
+                <a16:creationId xmlns:a16="http://schemas.microsoft.com/office/drawing/2014/main" id="{DC58EFE1-AC19-48FE-BE7C-0F8BF6E695B3}"/>
               </a:ext>
             </a:extLst>
           </p:cNvPr>
@@ -5009,7 +5019,7 @@
         </p:xfrm>
         <a:graphic xmlns:a="http://schemas.openxmlformats.org/drawingml/2006/main">
           <a:graphicData uri="http://schemas.openxmlformats.org/drawingml/2006/chart">
-            <c:chart xmlns:r="http://schemas.openxmlformats.org/officeDocument/2006/relationships" xmlns:c="http://schemas.openxmlformats.org/drawingml/2006/chart" r:id="Re133400f26cf4140"/>
+            <c:chart xmlns:r="http://schemas.openxmlformats.org/officeDocument/2006/relationships" xmlns:c="http://schemas.openxmlformats.org/drawingml/2006/chart" r:id="Rbf9a536475bc4e42"/>
           </a:graphicData>
         </a:graphic>
       </p:graphicFrame>
@@ -5018,7 +5028,7 @@
           <p:cNvPr id="4" name="">
             <a:extLst xmlns:a="http://schemas.openxmlformats.org/drawingml/2006/main">
               <a:ext uri="{FF2B5EF4-FFF2-40B4-BE49-F238E27FC236}">
-                <a16:creationId xmlns:a16="http://schemas.microsoft.com/office/drawing/2014/main" id="{BA0DFDAE-33BE-4B49-A155-DF6D143279DB}"/>
+                <a16:creationId xmlns:a16="http://schemas.microsoft.com/office/drawing/2014/main" id="{BB7DA1FD-C597-4E77-B670-23F67BA5BFBF}"/>
               </a:ext>
             </a:extLst>
           </p:cNvPr>
@@ -5087,7 +5097,7 @@
                 <a:ea typeface="Arial"/>
                 <a:cs typeface="Arial"/>
               </a:rPr>
-              <a:t>15-bin ECE (%) · same checkpoint and class predictions within each task</a:t>
+              <a:t>ConvNeXt-Tiny · clean official tests · seed 42 · 15-bin ECE (%)</a:t>
             </a:r>
           </a:p>
         </p:txBody>
@@ -5095,7 +5105,7 @@
     </p:spTree>
     <p:extLst>
       <p:ext uri="{BB962C8B-B14F-4D97-AF65-F5344CB8AC3E}">
-        <p14:creationId xmlns:p14="http://schemas.microsoft.com/office/powerpoint/2010/main" val="554887941"/>
+        <p14:creationId xmlns:p14="http://schemas.microsoft.com/office/powerpoint/2010/main" val="1696222842"/>
       </p:ext>
     </p:extLst>
   </p:cSld>
@@ -5126,7 +5136,7 @@
           <p:cNvPr id="5" name="">
             <a:extLst xmlns:a="http://schemas.openxmlformats.org/drawingml/2006/main">
               <a:ext uri="{FF2B5EF4-FFF2-40B4-BE49-F238E27FC236}">
-                <a16:creationId xmlns:a16="http://schemas.microsoft.com/office/drawing/2014/main" id="{93EE5334-EB0B-4913-B68C-56FCD80BA89B}"/>
+                <a16:creationId xmlns:a16="http://schemas.microsoft.com/office/drawing/2014/main" id="{BDD2DD9C-C76E-4DA9-A75A-D20073891C89}"/>
               </a:ext>
             </a:extLst>
           </p:cNvPr>
@@ -5156,7 +5166,7 @@
           <p:cNvPr id="2" name="">
             <a:extLst xmlns:a="http://schemas.openxmlformats.org/drawingml/2006/main">
               <a:ext uri="{FF2B5EF4-FFF2-40B4-BE49-F238E27FC236}">
-                <a16:creationId xmlns:a16="http://schemas.microsoft.com/office/drawing/2014/main" id="{E6D957B9-0862-45D2-B6B9-D1620168FFD3}"/>
+                <a16:creationId xmlns:a16="http://schemas.microsoft.com/office/drawing/2014/main" id="{1A2DF568-CF51-4005-B53D-C1FF57A5BBC9}"/>
               </a:ext>
             </a:extLst>
           </p:cNvPr>
@@ -5235,7 +5245,7 @@
           <p:cNvPr id="3" name="">
             <a:extLst xmlns:a="http://schemas.openxmlformats.org/drawingml/2006/main">
               <a:ext uri="{FF2B5EF4-FFF2-40B4-BE49-F238E27FC236}">
-                <a16:creationId xmlns:a16="http://schemas.microsoft.com/office/drawing/2014/main" id="{2CC1181C-E074-4395-B0EA-7BA684CF5B28}"/>
+                <a16:creationId xmlns:a16="http://schemas.microsoft.com/office/drawing/2014/main" id="{F20F0394-EB46-4078-807D-BE8CADC85DA9}"/>
               </a:ext>
             </a:extLst>
           </p:cNvPr>
@@ -6508,7 +6518,7 @@
           <p:cNvPr id="4" name="">
             <a:extLst xmlns:a="http://schemas.openxmlformats.org/drawingml/2006/main">
               <a:ext uri="{FF2B5EF4-FFF2-40B4-BE49-F238E27FC236}">
-                <a16:creationId xmlns:a16="http://schemas.microsoft.com/office/drawing/2014/main" id="{F657C6A6-47BF-478D-905A-F7E4C52AAFC8}"/>
+                <a16:creationId xmlns:a16="http://schemas.microsoft.com/office/drawing/2014/main" id="{675992E6-E76E-4019-9344-0E23D1832ADB}"/>
               </a:ext>
             </a:extLst>
           </p:cNvPr>
@@ -6577,7 +6587,7 @@
                 <a:ea typeface="Arial"/>
                 <a:cs typeface="Arial"/>
               </a:rPr>
-              <a:t>Temperature-scaled softmax rules; exact counts and Wilson intervals are in the write-up.</a:t>
+              <a:t>ConvNeXt official tests · accuracy among accepted predictions · calibration-only thresholds</a:t>
             </a:r>
           </a:p>
         </p:txBody>
@@ -6585,7 +6595,7 @@
     </p:spTree>
     <p:extLst>
       <p:ext uri="{BB962C8B-B14F-4D97-AF65-F5344CB8AC3E}">
-        <p14:creationId xmlns:p14="http://schemas.microsoft.com/office/powerpoint/2010/main" val="223232691"/>
+        <p14:creationId xmlns:p14="http://schemas.microsoft.com/office/powerpoint/2010/main" val="1936945281"/>
       </p:ext>
     </p:extLst>
   </p:cSld>
@@ -6616,7 +6626,7 @@
           <p:cNvPr id="4" name="">
             <a:extLst xmlns:a="http://schemas.openxmlformats.org/drawingml/2006/main">
               <a:ext uri="{FF2B5EF4-FFF2-40B4-BE49-F238E27FC236}">
-                <a16:creationId xmlns:a16="http://schemas.microsoft.com/office/drawing/2014/main" id="{6FBC164B-4A5A-4EEB-B0C2-3C190A845A08}"/>
+                <a16:creationId xmlns:a16="http://schemas.microsoft.com/office/drawing/2014/main" id="{B935E734-C770-417C-B1F2-637FE28C5149}"/>
               </a:ext>
             </a:extLst>
           </p:cNvPr>
@@ -6646,7 +6656,7 @@
           <p:cNvPr id="2" name="">
             <a:extLst xmlns:a="http://schemas.openxmlformats.org/drawingml/2006/main">
               <a:ext uri="{FF2B5EF4-FFF2-40B4-BE49-F238E27FC236}">
-                <a16:creationId xmlns:a16="http://schemas.microsoft.com/office/drawing/2014/main" id="{BD02C827-21F8-48E0-85BF-D6BC49B63C3D}"/>
+                <a16:creationId xmlns:a16="http://schemas.microsoft.com/office/drawing/2014/main" id="{40DFF06C-F118-4920-A8B2-B37AA81827BD}"/>
               </a:ext>
             </a:extLst>
           </p:cNvPr>
@@ -6725,7 +6735,7 @@
           <p:cNvPr id="3" name="">
             <a:extLst xmlns:a="http://schemas.openxmlformats.org/drawingml/2006/main">
               <a:ext uri="{FF2B5EF4-FFF2-40B4-BE49-F238E27FC236}">
-                <a16:creationId xmlns:a16="http://schemas.microsoft.com/office/drawing/2014/main" id="{2CDAE514-D243-491C-91B0-40AE4287046F}"/>
+                <a16:creationId xmlns:a16="http://schemas.microsoft.com/office/drawing/2014/main" id="{2A6440A4-6CBC-4316-B301-79D840C7C7FC}"/>
               </a:ext>
             </a:extLst>
           </p:cNvPr>
@@ -6735,7 +6745,7 @@
           <p:nvPr/>
         </p:nvPicPr>
         <p:blipFill>
-          <a:blip xmlns:r="http://schemas.openxmlformats.org/officeDocument/2006/relationships" xmlns:a="http://schemas.openxmlformats.org/drawingml/2006/main" r:embed="Rb7a0e9019c5e426d"/>
+          <a:blip xmlns:r="http://schemas.openxmlformats.org/officeDocument/2006/relationships" xmlns:a="http://schemas.openxmlformats.org/drawingml/2006/main" r:embed="Rbf99abc73cdd45a3"/>
           <a:stretch xmlns:a="http://schemas.openxmlformats.org/drawingml/2006/main"/>
         </p:blipFill>
         <p:spPr>
@@ -6751,7 +6761,7 @@
     </p:spTree>
     <p:extLst>
       <p:ext uri="{BB962C8B-B14F-4D97-AF65-F5344CB8AC3E}">
-        <p14:creationId xmlns:p14="http://schemas.microsoft.com/office/powerpoint/2010/main" val="1116036323"/>
+        <p14:creationId xmlns:p14="http://schemas.microsoft.com/office/powerpoint/2010/main" val="637975573"/>
       </p:ext>
     </p:extLst>
   </p:cSld>
@@ -6782,7 +6792,7 @@
           <p:cNvPr id="7" name="">
             <a:extLst xmlns:a="http://schemas.openxmlformats.org/drawingml/2006/main">
               <a:ext uri="{FF2B5EF4-FFF2-40B4-BE49-F238E27FC236}">
-                <a16:creationId xmlns:a16="http://schemas.microsoft.com/office/drawing/2014/main" id="{FEC7CE0F-5D29-4156-9B49-652616F177DF}"/>
+                <a16:creationId xmlns:a16="http://schemas.microsoft.com/office/drawing/2014/main" id="{4D4D3C06-5501-47CF-81FE-F72DBC9AFA89}"/>
               </a:ext>
             </a:extLst>
           </p:cNvPr>
@@ -6812,7 +6822,7 @@
           <p:cNvPr id="2" name="">
             <a:extLst xmlns:a="http://schemas.openxmlformats.org/drawingml/2006/main">
               <a:ext uri="{FF2B5EF4-FFF2-40B4-BE49-F238E27FC236}">
-                <a16:creationId xmlns:a16="http://schemas.microsoft.com/office/drawing/2014/main" id="{D2300B32-1E44-456C-A844-C8AB2DAB3DF5}"/>
+                <a16:creationId xmlns:a16="http://schemas.microsoft.com/office/drawing/2014/main" id="{99CCCA3D-0976-4B48-B2E3-CFCB66156B29}"/>
               </a:ext>
             </a:extLst>
           </p:cNvPr>
@@ -6891,7 +6901,7 @@
           <p:cNvPr id="3" name="">
             <a:extLst xmlns:a="http://schemas.openxmlformats.org/drawingml/2006/main">
               <a:ext uri="{FF2B5EF4-FFF2-40B4-BE49-F238E27FC236}">
-                <a16:creationId xmlns:a16="http://schemas.microsoft.com/office/drawing/2014/main" id="{588CE68C-02C3-4EBE-AFD5-4BF90545E1F9}"/>
+                <a16:creationId xmlns:a16="http://schemas.microsoft.com/office/drawing/2014/main" id="{7C021B7F-774B-47B1-A796-43B2FC8176FC}"/>
               </a:ext>
             </a:extLst>
           </p:cNvPr>
@@ -6970,7 +6980,7 @@
           <p:cNvPr id="4" name="">
             <a:extLst xmlns:a="http://schemas.openxmlformats.org/drawingml/2006/main">
               <a:ext uri="{FF2B5EF4-FFF2-40B4-BE49-F238E27FC236}">
-                <a16:creationId xmlns:a16="http://schemas.microsoft.com/office/drawing/2014/main" id="{85D9A8E0-CE02-49F8-886E-AD3CCB95BD14}"/>
+                <a16:creationId xmlns:a16="http://schemas.microsoft.com/office/drawing/2014/main" id="{D64385BC-B1D6-46BF-9254-30DB7A4694FD}"/>
               </a:ext>
             </a:extLst>
           </p:cNvPr>
@@ -7112,7 +7122,7 @@
           <p:cNvPr id="5" name="">
             <a:extLst xmlns:a="http://schemas.openxmlformats.org/drawingml/2006/main">
               <a:ext uri="{FF2B5EF4-FFF2-40B4-BE49-F238E27FC236}">
-                <a16:creationId xmlns:a16="http://schemas.microsoft.com/office/drawing/2014/main" id="{EF6AE9CB-1402-4C5E-9544-BC36B29BECF2}"/>
+                <a16:creationId xmlns:a16="http://schemas.microsoft.com/office/drawing/2014/main" id="{100B97C0-CD7B-4B88-9540-627203E524C3}"/>
               </a:ext>
             </a:extLst>
           </p:cNvPr>
@@ -7191,7 +7201,7 @@
           <p:cNvPr id="6" name="">
             <a:extLst xmlns:a="http://schemas.openxmlformats.org/drawingml/2006/main">
               <a:ext uri="{FF2B5EF4-FFF2-40B4-BE49-F238E27FC236}">
-                <a16:creationId xmlns:a16="http://schemas.microsoft.com/office/drawing/2014/main" id="{FC22FE13-5BD9-4A2B-A03E-B03D9733E8AC}"/>
+                <a16:creationId xmlns:a16="http://schemas.microsoft.com/office/drawing/2014/main" id="{B2C35B6D-AB0B-4BEE-9176-57450627FF0C}"/>
               </a:ext>
             </a:extLst>
           </p:cNvPr>
@@ -7331,7 +7341,7 @@
     </p:spTree>
     <p:extLst>
       <p:ext uri="{BB962C8B-B14F-4D97-AF65-F5344CB8AC3E}">
-        <p14:creationId xmlns:p14="http://schemas.microsoft.com/office/powerpoint/2010/main" val="863006598"/>
+        <p14:creationId xmlns:p14="http://schemas.microsoft.com/office/powerpoint/2010/main" val="940850814"/>
       </p:ext>
     </p:extLst>
   </p:cSld>
@@ -7362,7 +7372,7 @@
           <p:cNvPr id="5" name="">
             <a:extLst xmlns:a="http://schemas.openxmlformats.org/drawingml/2006/main">
               <a:ext uri="{FF2B5EF4-FFF2-40B4-BE49-F238E27FC236}">
-                <a16:creationId xmlns:a16="http://schemas.microsoft.com/office/drawing/2014/main" id="{93D236C7-BA6C-4215-AB3C-2F66658752DC}"/>
+                <a16:creationId xmlns:a16="http://schemas.microsoft.com/office/drawing/2014/main" id="{6F88DC07-D184-444E-9D08-62B6FD341E66}"/>
               </a:ext>
             </a:extLst>
           </p:cNvPr>
@@ -7392,7 +7402,7 @@
           <p:cNvPr id="2" name="">
             <a:extLst xmlns:a="http://schemas.openxmlformats.org/drawingml/2006/main">
               <a:ext uri="{FF2B5EF4-FFF2-40B4-BE49-F238E27FC236}">
-                <a16:creationId xmlns:a16="http://schemas.microsoft.com/office/drawing/2014/main" id="{6C1673E4-7285-4A60-AD6B-5B346059D170}"/>
+                <a16:creationId xmlns:a16="http://schemas.microsoft.com/office/drawing/2014/main" id="{5798A24E-5E6E-41A7-800D-FA21454C0C66}"/>
               </a:ext>
             </a:extLst>
           </p:cNvPr>
@@ -7471,7 +7481,7 @@
           <p:cNvPr id="3" name="">
             <a:extLst xmlns:a="http://schemas.openxmlformats.org/drawingml/2006/main">
               <a:ext uri="{FF2B5EF4-FFF2-40B4-BE49-F238E27FC236}">
-                <a16:creationId xmlns:a16="http://schemas.microsoft.com/office/drawing/2014/main" id="{6B8DA0C0-FED9-46CC-9DFB-48E24F7F0EDE}"/>
+                <a16:creationId xmlns:a16="http://schemas.microsoft.com/office/drawing/2014/main" id="{419B8E7F-4F77-4AC4-9E0F-DDFA60B0F9F0}"/>
               </a:ext>
             </a:extLst>
           </p:cNvPr>
@@ -7982,7 +7992,7 @@
           <p:cNvPr id="4" name="">
             <a:extLst xmlns:a="http://schemas.openxmlformats.org/drawingml/2006/main">
               <a:ext uri="{FF2B5EF4-FFF2-40B4-BE49-F238E27FC236}">
-                <a16:creationId xmlns:a16="http://schemas.microsoft.com/office/drawing/2014/main" id="{0BCF1B4C-9CE5-4260-B46D-44F4B1EABD15}"/>
+                <a16:creationId xmlns:a16="http://schemas.microsoft.com/office/drawing/2014/main" id="{BC886CE8-E8B3-4638-A557-88E3064B19A8}"/>
               </a:ext>
             </a:extLst>
           </p:cNvPr>
@@ -8051,7 +8061,7 @@
                 <a:ea typeface="Arial"/>
                 <a:cs typeface="Arial"/>
               </a:rPr>
-              <a:t>Priority: matched CIFAR corruption/OOD evaluation, then unfinished dataset checks. Full runs remain paused.</a:t>
+              <a:t>Next: matched corruption/OOD evaluation. Heavy experiments remain paused.</a:t>
             </a:r>
           </a:p>
         </p:txBody>
@@ -8059,7 +8069,7 @@
     </p:spTree>
     <p:extLst>
       <p:ext uri="{BB962C8B-B14F-4D97-AF65-F5344CB8AC3E}">
-        <p14:creationId xmlns:p14="http://schemas.microsoft.com/office/powerpoint/2010/main" val="751657009"/>
+        <p14:creationId xmlns:p14="http://schemas.microsoft.com/office/powerpoint/2010/main" val="1760383582"/>
       </p:ext>
     </p:extLst>
   </p:cSld>
@@ -8090,7 +8100,7 @@
           <p:cNvPr id="5" name="">
             <a:extLst xmlns:a="http://schemas.openxmlformats.org/drawingml/2006/main">
               <a:ext uri="{FF2B5EF4-FFF2-40B4-BE49-F238E27FC236}">
-                <a16:creationId xmlns:a16="http://schemas.microsoft.com/office/drawing/2014/main" id="{AD620242-91FA-49C5-A0F1-77A5461F35DA}"/>
+                <a16:creationId xmlns:a16="http://schemas.microsoft.com/office/drawing/2014/main" id="{99C83031-14A6-4FE1-AC4F-837CD461B9A9}"/>
               </a:ext>
             </a:extLst>
           </p:cNvPr>
@@ -8120,7 +8130,7 @@
           <p:cNvPr id="2" name="">
             <a:extLst xmlns:a="http://schemas.openxmlformats.org/drawingml/2006/main">
               <a:ext uri="{FF2B5EF4-FFF2-40B4-BE49-F238E27FC236}">
-                <a16:creationId xmlns:a16="http://schemas.microsoft.com/office/drawing/2014/main" id="{818F53B3-1B85-4BBC-80FA-432244B33242}"/>
+                <a16:creationId xmlns:a16="http://schemas.microsoft.com/office/drawing/2014/main" id="{0B002E55-B3A5-40E6-AD5A-08584432EE34}"/>
               </a:ext>
             </a:extLst>
           </p:cNvPr>
@@ -8199,7 +8209,7 @@
           <p:cNvPr id="3" name="">
             <a:extLst xmlns:a="http://schemas.openxmlformats.org/drawingml/2006/main">
               <a:ext uri="{FF2B5EF4-FFF2-40B4-BE49-F238E27FC236}">
-                <a16:creationId xmlns:a16="http://schemas.microsoft.com/office/drawing/2014/main" id="{9E1479C0-E85A-43DF-9079-48875F4C9F6C}"/>
+                <a16:creationId xmlns:a16="http://schemas.microsoft.com/office/drawing/2014/main" id="{29BCDC7A-6737-4134-913F-444DECC9B81E}"/>
               </a:ext>
             </a:extLst>
           </p:cNvPr>
@@ -8278,7 +8288,7 @@
           <p:cNvPr id="4" name="">
             <a:extLst xmlns:a="http://schemas.openxmlformats.org/drawingml/2006/main">
               <a:ext uri="{FF2B5EF4-FFF2-40B4-BE49-F238E27FC236}">
-                <a16:creationId xmlns:a16="http://schemas.microsoft.com/office/drawing/2014/main" id="{0A0D2BBC-3F85-4DD7-8317-483DF476A1E0}"/>
+                <a16:creationId xmlns:a16="http://schemas.microsoft.com/office/drawing/2014/main" id="{38661FE9-8F16-4234-A94D-B3168DDE5BF9}"/>
               </a:ext>
             </a:extLst>
           </p:cNvPr>
@@ -8355,7 +8365,7 @@
     </p:spTree>
     <p:extLst>
       <p:ext uri="{BB962C8B-B14F-4D97-AF65-F5344CB8AC3E}">
-        <p14:creationId xmlns:p14="http://schemas.microsoft.com/office/powerpoint/2010/main" val="135817369"/>
+        <p14:creationId xmlns:p14="http://schemas.microsoft.com/office/powerpoint/2010/main" val="7336305"/>
       </p:ext>
     </p:extLst>
   </p:cSld>

</xml_diff>